<commit_message>
Add workshop capacity tools and finish the Sprint 1 review
</commit_message>
<xml_diff>
--- a/docs/slides/Presentation_Group11_Sprint1.pptx
+++ b/docs/slides/Presentation_Group11_Sprint1.pptx
@@ -8772,10 +8772,9 @@
             <a:tbl>
               <a:tblPr/>
               <a:tblGrid>
-                <a:gridCol w="2743200"/>
-                <a:gridCol w="731520"/>
-                <a:gridCol w="777240"/>
-                <a:gridCol w="3977640"/>
+                <a:gridCol w="3291840"/>
+                <a:gridCol w="822960"/>
+                <a:gridCol w="4114800"/>
               </a:tblGrid>
               <a:tr h="365760">
                 <a:tc>
@@ -8796,74 +8795,6 @@
                           <a:cs typeface="Arial" pitchFamily="34" charset="-120"/>
                         </a:rPr>
                         <a:t>Work</a:t>
-                      </a:r>
-                      <a:endParaRPr lang="en-US" sz="950" dirty="0">
-                        <a:latin typeface="Arial" charset="0"/>
-                        <a:ea typeface="Arial" charset="0"/>
-                        <a:cs typeface="Arial" charset="0"/>
-                      </a:endParaRPr>
-                    </a:p>
-                  </a:txBody>
-                  <a:tcPr marL="63500" marR="63500" marT="38100" marB="38100" anchor="ctr">
-                    <a:lnL w="9525" cap="flat" cmpd="sng" algn="ctr">
-                      <a:solidFill>
-                        <a:srgbClr val="C9D3CE"/>
-                      </a:solidFill>
-                      <a:prstDash val="solid"/>
-                      <a:round/>
-                      <a:headEnd type="none" w="med" len="med"/>
-                      <a:tailEnd type="none" w="med" len="med"/>
-                    </a:lnL>
-                    <a:lnR w="9525" cap="flat" cmpd="sng" algn="ctr">
-                      <a:solidFill>
-                        <a:srgbClr val="C9D3CE"/>
-                      </a:solidFill>
-                      <a:prstDash val="solid"/>
-                      <a:round/>
-                      <a:headEnd type="none" w="med" len="med"/>
-                      <a:tailEnd type="none" w="med" len="med"/>
-                    </a:lnR>
-                    <a:lnT w="9525" cap="flat" cmpd="sng" algn="ctr">
-                      <a:solidFill>
-                        <a:srgbClr val="C9D3CE"/>
-                      </a:solidFill>
-                      <a:prstDash val="solid"/>
-                      <a:round/>
-                      <a:headEnd type="none" w="med" len="med"/>
-                      <a:tailEnd type="none" w="med" len="med"/>
-                    </a:lnT>
-                    <a:lnB w="9525" cap="flat" cmpd="sng" algn="ctr">
-                      <a:solidFill>
-                        <a:srgbClr val="C9D3CE"/>
-                      </a:solidFill>
-                      <a:prstDash val="solid"/>
-                      <a:round/>
-                      <a:headEnd type="none" w="med" len="med"/>
-                      <a:tailEnd type="none" w="med" len="med"/>
-                    </a:lnB>
-                    <a:solidFill>
-                      <a:srgbClr val="203731"/>
-                    </a:solidFill>
-                  </a:tcPr>
-                </a:tc>
-                <a:tc>
-                  <a:txBody>
-                    <a:bodyPr/>
-                    <a:lstStyle/>
-                    <a:p>
-                      <a:pPr indent="0" marL="0">
-                        <a:buNone/>
-                      </a:pPr>
-                      <a:r>
-                        <a:rPr lang="en-US" sz="950" b="1" dirty="0">
-                          <a:solidFill>
-                            <a:srgbClr val="FFFFFF"/>
-                          </a:solidFill>
-                          <a:latin typeface="Arial" pitchFamily="34" charset="0"/>
-                          <a:ea typeface="Arial" pitchFamily="34" charset="-122"/>
-                          <a:cs typeface="Arial" pitchFamily="34" charset="-120"/>
-                        </a:rPr>
-                        <a:t>Owner</a:t>
                       </a:r>
                       <a:endParaRPr lang="en-US" sz="950" dirty="0">
                         <a:latin typeface="Arial" charset="0"/>
@@ -9125,74 +9056,6 @@
                     <a:bodyPr/>
                     <a:lstStyle/>
                     <a:p>
-                      <a:pPr indent="0" marL="0">
-                        <a:buNone/>
-                      </a:pPr>
-                      <a:r>
-                        <a:rPr lang="en-US" sz="950" dirty="0">
-                          <a:solidFill>
-                            <a:srgbClr val="60726C"/>
-                          </a:solidFill>
-                          <a:latin typeface="Arial" pitchFamily="34" charset="0"/>
-                          <a:ea typeface="Arial" pitchFamily="34" charset="-122"/>
-                          <a:cs typeface="Arial" pitchFamily="34" charset="-120"/>
-                        </a:rPr>
-                        <a:t>TBD</a:t>
-                      </a:r>
-                      <a:endParaRPr lang="en-US" sz="950" dirty="0">
-                        <a:latin typeface="Arial" charset="0"/>
-                        <a:ea typeface="Arial" charset="0"/>
-                        <a:cs typeface="Arial" charset="0"/>
-                      </a:endParaRPr>
-                    </a:p>
-                  </a:txBody>
-                  <a:tcPr marL="63500" marR="63500" marT="38100" marB="38100" anchor="ctr">
-                    <a:lnL w="9525" cap="flat" cmpd="sng" algn="ctr">
-                      <a:solidFill>
-                        <a:srgbClr val="C9D3CE"/>
-                      </a:solidFill>
-                      <a:prstDash val="solid"/>
-                      <a:round/>
-                      <a:headEnd type="none" w="med" len="med"/>
-                      <a:tailEnd type="none" w="med" len="med"/>
-                    </a:lnL>
-                    <a:lnR w="9525" cap="flat" cmpd="sng" algn="ctr">
-                      <a:solidFill>
-                        <a:srgbClr val="C9D3CE"/>
-                      </a:solidFill>
-                      <a:prstDash val="solid"/>
-                      <a:round/>
-                      <a:headEnd type="none" w="med" len="med"/>
-                      <a:tailEnd type="none" w="med" len="med"/>
-                    </a:lnR>
-                    <a:lnT w="9525" cap="flat" cmpd="sng" algn="ctr">
-                      <a:solidFill>
-                        <a:srgbClr val="C9D3CE"/>
-                      </a:solidFill>
-                      <a:prstDash val="solid"/>
-                      <a:round/>
-                      <a:headEnd type="none" w="med" len="med"/>
-                      <a:tailEnd type="none" w="med" len="med"/>
-                    </a:lnT>
-                    <a:lnB w="9525" cap="flat" cmpd="sng" algn="ctr">
-                      <a:solidFill>
-                        <a:srgbClr val="C9D3CE"/>
-                      </a:solidFill>
-                      <a:prstDash val="solid"/>
-                      <a:round/>
-                      <a:headEnd type="none" w="med" len="med"/>
-                      <a:tailEnd type="none" w="med" len="med"/>
-                    </a:lnB>
-                    <a:solidFill>
-                      <a:srgbClr val="FFFFFF"/>
-                    </a:solidFill>
-                  </a:tcPr>
-                </a:tc>
-                <a:tc>
-                  <a:txBody>
-                    <a:bodyPr/>
-                    <a:lstStyle/>
-                    <a:p>
                       <a:pPr algn="ctr" indent="0" marL="0">
                         <a:buNone/>
                       </a:pPr>
@@ -9399,74 +9262,6 @@
                     <a:bodyPr/>
                     <a:lstStyle/>
                     <a:p>
-                      <a:pPr indent="0" marL="0">
-                        <a:buNone/>
-                      </a:pPr>
-                      <a:r>
-                        <a:rPr lang="en-US" sz="950" dirty="0">
-                          <a:solidFill>
-                            <a:srgbClr val="60726C"/>
-                          </a:solidFill>
-                          <a:latin typeface="Arial" pitchFamily="34" charset="0"/>
-                          <a:ea typeface="Arial" pitchFamily="34" charset="-122"/>
-                          <a:cs typeface="Arial" pitchFamily="34" charset="-120"/>
-                        </a:rPr>
-                        <a:t>TBD</a:t>
-                      </a:r>
-                      <a:endParaRPr lang="en-US" sz="950" dirty="0">
-                        <a:latin typeface="Arial" charset="0"/>
-                        <a:ea typeface="Arial" charset="0"/>
-                        <a:cs typeface="Arial" charset="0"/>
-                      </a:endParaRPr>
-                    </a:p>
-                  </a:txBody>
-                  <a:tcPr marL="63500" marR="63500" marT="38100" marB="38100" anchor="ctr">
-                    <a:lnL w="9525" cap="flat" cmpd="sng" algn="ctr">
-                      <a:solidFill>
-                        <a:srgbClr val="C9D3CE"/>
-                      </a:solidFill>
-                      <a:prstDash val="solid"/>
-                      <a:round/>
-                      <a:headEnd type="none" w="med" len="med"/>
-                      <a:tailEnd type="none" w="med" len="med"/>
-                    </a:lnL>
-                    <a:lnR w="9525" cap="flat" cmpd="sng" algn="ctr">
-                      <a:solidFill>
-                        <a:srgbClr val="C9D3CE"/>
-                      </a:solidFill>
-                      <a:prstDash val="solid"/>
-                      <a:round/>
-                      <a:headEnd type="none" w="med" len="med"/>
-                      <a:tailEnd type="none" w="med" len="med"/>
-                    </a:lnR>
-                    <a:lnT w="9525" cap="flat" cmpd="sng" algn="ctr">
-                      <a:solidFill>
-                        <a:srgbClr val="C9D3CE"/>
-                      </a:solidFill>
-                      <a:prstDash val="solid"/>
-                      <a:round/>
-                      <a:headEnd type="none" w="med" len="med"/>
-                      <a:tailEnd type="none" w="med" len="med"/>
-                    </a:lnT>
-                    <a:lnB w="9525" cap="flat" cmpd="sng" algn="ctr">
-                      <a:solidFill>
-                        <a:srgbClr val="C9D3CE"/>
-                      </a:solidFill>
-                      <a:prstDash val="solid"/>
-                      <a:round/>
-                      <a:headEnd type="none" w="med" len="med"/>
-                      <a:tailEnd type="none" w="med" len="med"/>
-                    </a:lnB>
-                    <a:solidFill>
-                      <a:srgbClr val="FFFFFF"/>
-                    </a:solidFill>
-                  </a:tcPr>
-                </a:tc>
-                <a:tc>
-                  <a:txBody>
-                    <a:bodyPr/>
-                    <a:lstStyle/>
-                    <a:p>
                       <a:pPr algn="ctr" indent="0" marL="0">
                         <a:buNone/>
                       </a:pPr>
@@ -9673,74 +9468,6 @@
                     <a:bodyPr/>
                     <a:lstStyle/>
                     <a:p>
-                      <a:pPr indent="0" marL="0">
-                        <a:buNone/>
-                      </a:pPr>
-                      <a:r>
-                        <a:rPr lang="en-US" sz="950" dirty="0">
-                          <a:solidFill>
-                            <a:srgbClr val="60726C"/>
-                          </a:solidFill>
-                          <a:latin typeface="Arial" pitchFamily="34" charset="0"/>
-                          <a:ea typeface="Arial" pitchFamily="34" charset="-122"/>
-                          <a:cs typeface="Arial" pitchFamily="34" charset="-120"/>
-                        </a:rPr>
-                        <a:t>TBD</a:t>
-                      </a:r>
-                      <a:endParaRPr lang="en-US" sz="950" dirty="0">
-                        <a:latin typeface="Arial" charset="0"/>
-                        <a:ea typeface="Arial" charset="0"/>
-                        <a:cs typeface="Arial" charset="0"/>
-                      </a:endParaRPr>
-                    </a:p>
-                  </a:txBody>
-                  <a:tcPr marL="63500" marR="63500" marT="38100" marB="38100" anchor="ctr">
-                    <a:lnL w="9525" cap="flat" cmpd="sng" algn="ctr">
-                      <a:solidFill>
-                        <a:srgbClr val="C9D3CE"/>
-                      </a:solidFill>
-                      <a:prstDash val="solid"/>
-                      <a:round/>
-                      <a:headEnd type="none" w="med" len="med"/>
-                      <a:tailEnd type="none" w="med" len="med"/>
-                    </a:lnL>
-                    <a:lnR w="9525" cap="flat" cmpd="sng" algn="ctr">
-                      <a:solidFill>
-                        <a:srgbClr val="C9D3CE"/>
-                      </a:solidFill>
-                      <a:prstDash val="solid"/>
-                      <a:round/>
-                      <a:headEnd type="none" w="med" len="med"/>
-                      <a:tailEnd type="none" w="med" len="med"/>
-                    </a:lnR>
-                    <a:lnT w="9525" cap="flat" cmpd="sng" algn="ctr">
-                      <a:solidFill>
-                        <a:srgbClr val="C9D3CE"/>
-                      </a:solidFill>
-                      <a:prstDash val="solid"/>
-                      <a:round/>
-                      <a:headEnd type="none" w="med" len="med"/>
-                      <a:tailEnd type="none" w="med" len="med"/>
-                    </a:lnT>
-                    <a:lnB w="9525" cap="flat" cmpd="sng" algn="ctr">
-                      <a:solidFill>
-                        <a:srgbClr val="C9D3CE"/>
-                      </a:solidFill>
-                      <a:prstDash val="solid"/>
-                      <a:round/>
-                      <a:headEnd type="none" w="med" len="med"/>
-                      <a:tailEnd type="none" w="med" len="med"/>
-                    </a:lnB>
-                    <a:solidFill>
-                      <a:srgbClr val="FFFFFF"/>
-                    </a:solidFill>
-                  </a:tcPr>
-                </a:tc>
-                <a:tc>
-                  <a:txBody>
-                    <a:bodyPr/>
-                    <a:lstStyle/>
-                    <a:p>
                       <a:pPr algn="ctr" indent="0" marL="0">
                         <a:buNone/>
                       </a:pPr>
@@ -9947,74 +9674,6 @@
                     <a:bodyPr/>
                     <a:lstStyle/>
                     <a:p>
-                      <a:pPr indent="0" marL="0">
-                        <a:buNone/>
-                      </a:pPr>
-                      <a:r>
-                        <a:rPr lang="en-US" sz="950" dirty="0">
-                          <a:solidFill>
-                            <a:srgbClr val="60726C"/>
-                          </a:solidFill>
-                          <a:latin typeface="Arial" pitchFamily="34" charset="0"/>
-                          <a:ea typeface="Arial" pitchFamily="34" charset="-122"/>
-                          <a:cs typeface="Arial" pitchFamily="34" charset="-120"/>
-                        </a:rPr>
-                        <a:t>TBD</a:t>
-                      </a:r>
-                      <a:endParaRPr lang="en-US" sz="950" dirty="0">
-                        <a:latin typeface="Arial" charset="0"/>
-                        <a:ea typeface="Arial" charset="0"/>
-                        <a:cs typeface="Arial" charset="0"/>
-                      </a:endParaRPr>
-                    </a:p>
-                  </a:txBody>
-                  <a:tcPr marL="63500" marR="63500" marT="38100" marB="38100" anchor="ctr">
-                    <a:lnL w="9525" cap="flat" cmpd="sng" algn="ctr">
-                      <a:solidFill>
-                        <a:srgbClr val="C9D3CE"/>
-                      </a:solidFill>
-                      <a:prstDash val="solid"/>
-                      <a:round/>
-                      <a:headEnd type="none" w="med" len="med"/>
-                      <a:tailEnd type="none" w="med" len="med"/>
-                    </a:lnL>
-                    <a:lnR w="9525" cap="flat" cmpd="sng" algn="ctr">
-                      <a:solidFill>
-                        <a:srgbClr val="C9D3CE"/>
-                      </a:solidFill>
-                      <a:prstDash val="solid"/>
-                      <a:round/>
-                      <a:headEnd type="none" w="med" len="med"/>
-                      <a:tailEnd type="none" w="med" len="med"/>
-                    </a:lnR>
-                    <a:lnT w="9525" cap="flat" cmpd="sng" algn="ctr">
-                      <a:solidFill>
-                        <a:srgbClr val="C9D3CE"/>
-                      </a:solidFill>
-                      <a:prstDash val="solid"/>
-                      <a:round/>
-                      <a:headEnd type="none" w="med" len="med"/>
-                      <a:tailEnd type="none" w="med" len="med"/>
-                    </a:lnT>
-                    <a:lnB w="9525" cap="flat" cmpd="sng" algn="ctr">
-                      <a:solidFill>
-                        <a:srgbClr val="C9D3CE"/>
-                      </a:solidFill>
-                      <a:prstDash val="solid"/>
-                      <a:round/>
-                      <a:headEnd type="none" w="med" len="med"/>
-                      <a:tailEnd type="none" w="med" len="med"/>
-                    </a:lnB>
-                    <a:solidFill>
-                      <a:srgbClr val="FFFFFF"/>
-                    </a:solidFill>
-                  </a:tcPr>
-                </a:tc>
-                <a:tc>
-                  <a:txBody>
-                    <a:bodyPr/>
-                    <a:lstStyle/>
-                    <a:p>
                       <a:pPr algn="ctr" indent="0" marL="0">
                         <a:buNone/>
                       </a:pPr>
@@ -10221,74 +9880,6 @@
                     <a:bodyPr/>
                     <a:lstStyle/>
                     <a:p>
-                      <a:pPr indent="0" marL="0">
-                        <a:buNone/>
-                      </a:pPr>
-                      <a:r>
-                        <a:rPr lang="en-US" sz="950" dirty="0">
-                          <a:solidFill>
-                            <a:srgbClr val="60726C"/>
-                          </a:solidFill>
-                          <a:latin typeface="Arial" pitchFamily="34" charset="0"/>
-                          <a:ea typeface="Arial" pitchFamily="34" charset="-122"/>
-                          <a:cs typeface="Arial" pitchFamily="34" charset="-120"/>
-                        </a:rPr>
-                        <a:t>TBD</a:t>
-                      </a:r>
-                      <a:endParaRPr lang="en-US" sz="950" dirty="0">
-                        <a:latin typeface="Arial" charset="0"/>
-                        <a:ea typeface="Arial" charset="0"/>
-                        <a:cs typeface="Arial" charset="0"/>
-                      </a:endParaRPr>
-                    </a:p>
-                  </a:txBody>
-                  <a:tcPr marL="63500" marR="63500" marT="38100" marB="38100" anchor="ctr">
-                    <a:lnL w="9525" cap="flat" cmpd="sng" algn="ctr">
-                      <a:solidFill>
-                        <a:srgbClr val="C9D3CE"/>
-                      </a:solidFill>
-                      <a:prstDash val="solid"/>
-                      <a:round/>
-                      <a:headEnd type="none" w="med" len="med"/>
-                      <a:tailEnd type="none" w="med" len="med"/>
-                    </a:lnL>
-                    <a:lnR w="9525" cap="flat" cmpd="sng" algn="ctr">
-                      <a:solidFill>
-                        <a:srgbClr val="C9D3CE"/>
-                      </a:solidFill>
-                      <a:prstDash val="solid"/>
-                      <a:round/>
-                      <a:headEnd type="none" w="med" len="med"/>
-                      <a:tailEnd type="none" w="med" len="med"/>
-                    </a:lnR>
-                    <a:lnT w="9525" cap="flat" cmpd="sng" algn="ctr">
-                      <a:solidFill>
-                        <a:srgbClr val="C9D3CE"/>
-                      </a:solidFill>
-                      <a:prstDash val="solid"/>
-                      <a:round/>
-                      <a:headEnd type="none" w="med" len="med"/>
-                      <a:tailEnd type="none" w="med" len="med"/>
-                    </a:lnT>
-                    <a:lnB w="9525" cap="flat" cmpd="sng" algn="ctr">
-                      <a:solidFill>
-                        <a:srgbClr val="C9D3CE"/>
-                      </a:solidFill>
-                      <a:prstDash val="solid"/>
-                      <a:round/>
-                      <a:headEnd type="none" w="med" len="med"/>
-                      <a:tailEnd type="none" w="med" len="med"/>
-                    </a:lnB>
-                    <a:solidFill>
-                      <a:srgbClr val="FFFFFF"/>
-                    </a:solidFill>
-                  </a:tcPr>
-                </a:tc>
-                <a:tc>
-                  <a:txBody>
-                    <a:bodyPr/>
-                    <a:lstStyle/>
-                    <a:p>
                       <a:pPr algn="ctr" indent="0" marL="0">
                         <a:buNone/>
                       </a:pPr>
@@ -10440,74 +10031,6 @@
                           <a:cs typeface="Arial" pitchFamily="34" charset="-120"/>
                         </a:rPr>
                         <a:t>Demo video</a:t>
-                      </a:r>
-                      <a:endParaRPr lang="en-US" sz="950" dirty="0">
-                        <a:latin typeface="Arial" charset="0"/>
-                        <a:ea typeface="Arial" charset="0"/>
-                        <a:cs typeface="Arial" charset="0"/>
-                      </a:endParaRPr>
-                    </a:p>
-                  </a:txBody>
-                  <a:tcPr marL="63500" marR="63500" marT="38100" marB="38100" anchor="ctr">
-                    <a:lnL w="9525" cap="flat" cmpd="sng" algn="ctr">
-                      <a:solidFill>
-                        <a:srgbClr val="C9D3CE"/>
-                      </a:solidFill>
-                      <a:prstDash val="solid"/>
-                      <a:round/>
-                      <a:headEnd type="none" w="med" len="med"/>
-                      <a:tailEnd type="none" w="med" len="med"/>
-                    </a:lnL>
-                    <a:lnR w="9525" cap="flat" cmpd="sng" algn="ctr">
-                      <a:solidFill>
-                        <a:srgbClr val="C9D3CE"/>
-                      </a:solidFill>
-                      <a:prstDash val="solid"/>
-                      <a:round/>
-                      <a:headEnd type="none" w="med" len="med"/>
-                      <a:tailEnd type="none" w="med" len="med"/>
-                    </a:lnR>
-                    <a:lnT w="9525" cap="flat" cmpd="sng" algn="ctr">
-                      <a:solidFill>
-                        <a:srgbClr val="C9D3CE"/>
-                      </a:solidFill>
-                      <a:prstDash val="solid"/>
-                      <a:round/>
-                      <a:headEnd type="none" w="med" len="med"/>
-                      <a:tailEnd type="none" w="med" len="med"/>
-                    </a:lnT>
-                    <a:lnB w="9525" cap="flat" cmpd="sng" algn="ctr">
-                      <a:solidFill>
-                        <a:srgbClr val="C9D3CE"/>
-                      </a:solidFill>
-                      <a:prstDash val="solid"/>
-                      <a:round/>
-                      <a:headEnd type="none" w="med" len="med"/>
-                      <a:tailEnd type="none" w="med" len="med"/>
-                    </a:lnB>
-                    <a:solidFill>
-                      <a:srgbClr val="FFFFFF"/>
-                    </a:solidFill>
-                  </a:tcPr>
-                </a:tc>
-                <a:tc>
-                  <a:txBody>
-                    <a:bodyPr/>
-                    <a:lstStyle/>
-                    <a:p>
-                      <a:pPr indent="0" marL="0">
-                        <a:buNone/>
-                      </a:pPr>
-                      <a:r>
-                        <a:rPr lang="en-US" sz="950" dirty="0">
-                          <a:solidFill>
-                            <a:srgbClr val="60726C"/>
-                          </a:solidFill>
-                          <a:latin typeface="Arial" pitchFamily="34" charset="0"/>
-                          <a:ea typeface="Arial" pitchFamily="34" charset="-122"/>
-                          <a:cs typeface="Arial" pitchFamily="34" charset="-120"/>
-                        </a:rPr>
-                        <a:t>TBD</a:t>
                       </a:r>
                       <a:endParaRPr lang="en-US" sz="950" dirty="0">
                         <a:latin typeface="Arial" charset="0"/>

</xml_diff>